<commit_message>
docs: sharper workflow diagram and locked-file save handling
Redesign matplotlib workflow: anchored boxes, swimlanes, orthogonal
fan-out preprocess -> ranks -> Git -> ensemble. Placeholder frames use
lighter styling. Saving skips paths with PermissionError when PPTX open.

Co-authored-by: Cursor <cursoragent@cursor.com>
</commit_message>
<xml_diff>
--- a/docs/FastUrduGuard_Presentation.pptx
+++ b/docs/FastUrduGuard_Presentation.pptx
@@ -3295,8 +3295,8 @@
         </p:blipFill>
         <p:spPr>
           <a:xfrm>
-            <a:off x="822960" y="1051560"/>
-            <a:ext cx="10515600" cy="3928734"/>
+            <a:off x="822960" y="1024128"/>
+            <a:ext cx="10515600" cy="4140518"/>
           </a:xfrm>
           <a:prstGeom prst="rect">
             <a:avLst/>
@@ -3311,8 +3311,8 @@
         </p:nvSpPr>
         <p:spPr>
           <a:xfrm>
-            <a:off x="457200" y="228600"/>
-            <a:ext cx="10972800" cy="640080"/>
+            <a:off x="457200" y="201168"/>
+            <a:ext cx="10972800" cy="621792"/>
           </a:xfrm>
           <a:prstGeom prst="rect">
             <a:avLst/>
@@ -3368,8 +3368,8 @@
         </p:blipFill>
         <p:spPr>
           <a:xfrm>
-            <a:off x="822960" y="1051560"/>
-            <a:ext cx="10515600" cy="4024193"/>
+            <a:off x="822960" y="1024128"/>
+            <a:ext cx="10515600" cy="4243285"/>
           </a:xfrm>
           <a:prstGeom prst="rect">
             <a:avLst/>
@@ -3384,8 +3384,8 @@
         </p:nvSpPr>
         <p:spPr>
           <a:xfrm>
-            <a:off x="457200" y="228600"/>
-            <a:ext cx="10972800" cy="640080"/>
+            <a:off x="457200" y="201168"/>
+            <a:ext cx="10972800" cy="621792"/>
           </a:xfrm>
           <a:prstGeom prst="rect">
             <a:avLst/>
@@ -3639,7 +3639,7 @@
               <a:defRPr sz="2000"/>
             </a:pPr>
             <a:r>
-              <a:t>Islam et al., “Unified LLMs for Misinformation Detection in Low-Resource Linguistic Settings,” arXiv:2506.01587, 2025.</a:t>
+              <a:t>Islam et al., "Unified LLMs for Misinformation Detection in Low-Resource Linguistic Settings," arXiv:2506.01587, 2025.</a:t>
             </a:r>
           </a:p>
           <a:p>
@@ -3884,8 +3884,8 @@
         </p:blipFill>
         <p:spPr>
           <a:xfrm>
-            <a:off x="411480" y="960120"/>
-            <a:ext cx="11292840" cy="4882109"/>
+            <a:off x="365760" y="868680"/>
+            <a:ext cx="11384280" cy="5486709"/>
           </a:xfrm>
           <a:prstGeom prst="rect">
             <a:avLst/>
@@ -3900,7 +3900,7 @@
         </p:nvSpPr>
         <p:spPr>
           <a:xfrm>
-            <a:off x="457200" y="228600"/>
+            <a:off x="457200" y="182880"/>
             <a:ext cx="10972800" cy="594360"/>
           </a:xfrm>
           <a:prstGeom prst="rect">
@@ -3918,7 +3918,7 @@
               <a:defRPr sz="2800" b="1"/>
             </a:pPr>
             <a:r>
-              <a:t>Workflow — data, training coordination, aggregation</a:t>
+              <a:t>End-to-end workflow</a:t>
             </a:r>
           </a:p>
         </p:txBody>

</xml_diff>